<commit_message>
Pitch deck: Raven branding, fresh console screenshots, updated test counts
</commit_message>
<xml_diff>
--- a/docs/pitch/Raven_Pitch.pptx
+++ b/docs/pitch/Raven_Pitch.pptx
@@ -520,7 +520,7 @@
           <a:p>
             <a:r>
               <a:rPr lang="en-US" dirty="0"/>
-              <a:t>One-line promise: network security for places with no security team. Sentinel runs on the gateway Mac, spots port scans, password guessing, malware check-ins, DNS tunnelling and unusual traffic, explains each in plain English, keeps a permanent history, and can alert Slack, Discord or Telegram. The screenshot on the right is the real console during a live test on this Mac.</a:t>
+              <a:t>One-line promise: network security for places with no security team. Raven runs on the gateway Mac, spots port scans, password guessing, malware check-ins, DNS tunnelling and unusual traffic, explains each in plain English, keeps a permanent history, and can alert Slack, Discord or Telegram. The screenshot on the right is the real console during a live test on this Mac.</a:t>
             </a:r>
             <a:endParaRPr lang="en-US" dirty="0"/>
           </a:p>
@@ -608,7 +608,7 @@
           <a:p>
             <a:r>
               <a:rPr lang="en-US" dirty="0"/>
-              <a:t>A single short window misses a patient attacker who probes slowly. Sentinel counts over 10 seconds, 5 minutes and 1 hour. The default scan thresholds are 20 distinct ports in 10 seconds, 15 in 5 minutes and 60 in an hour. Expressed as a probing rate, that is the chart: a scan must go faster than 120 probes a minute to trip the short clock, but the 5-minute clock catches 3 a minute and the 1-hour clock catches 1 a minute. In the live loopback test a fast scan was CRITICAL through the 10-second window and a scan of one probe per second was HIGH through the 5-minute window.</a:t>
+              <a:t>A single short window misses a patient attacker who probes slowly. Raven counts over 10 seconds, 5 minutes and 1 hour. The default scan thresholds are 20 distinct ports in 10 seconds, 15 in 5 minutes and 60 in an hour. Expressed as a probing rate, that is the chart: a scan must go faster than 120 probes a minute to trip the short clock, but the 5-minute clock catches 3 a minute and the 1-hour clock catches 1 a minute. In the live loopback test a fast scan was CRITICAL through the 10-second window and a scan of one probe per second was HIGH through the 5-minute window.</a:t>
             </a:r>
             <a:endParaRPr lang="en-US" dirty="0"/>
           </a:p>
@@ -784,7 +784,7 @@
           <a:p>
             <a:r>
               <a:rPr lang="en-US" dirty="0"/>
-              <a:t>These come from the live loopback test in demo.md: Sentinel captured lo0 on this Mac with only the 10-second window while the four attack scripts ran against 127.0.0.1. Bars show seconds from attack start to alert. The DNS tunnel was fastest, 1.7 s; the beacon needed about 12 s because it needs ten check-ins one second apart. The control, ordinary web browsing, raised nothing. Stability: port scan, brute force, DNS and the control were right in about 15 live runs each; the beacon missed 2 of 21 early attempts because the attack started before tcpdump was capturing, and after the driver waited for tcpdump it was 4 of 4. Real beacons check in every 30 to 300 seconds, so they need minutes, not seconds.</a:t>
+              <a:t>These come from the live loopback test in demo.md: Raven captured lo0 on this Mac with only the 10-second window while the four attack scripts ran against 127.0.0.1. Bars show seconds from attack start to alert. The DNS tunnel was fastest, 1.7 s; the beacon needed about 12 s because it needs ten check-ins one second apart. The control, ordinary web browsing, raised nothing. Stability: port scan, brute force, DNS and the control were right in about 15 live runs each; the beacon missed 2 of 21 early attempts because the attack started before tcpdump was capturing, and after the driver waited for tcpdump it was 4 of 4. Real beacons check in every 30 to 300 seconds, so they need minutes, not seconds.</a:t>
             </a:r>
             <a:endParaRPr lang="en-US" dirty="0"/>
           </a:p>
@@ -1136,7 +1136,7 @@
           <a:p>
             <a:r>
               <a:rPr lang="en-US" dirty="0"/>
-              <a:t>Five points. One: strings from the network are hostile and go through one sanitiser. Two: the console is local only, with a token, a strict content-security policy and no way for network text to become markup; the test suite fails if code that builds HTML from strings is added. Three: Sentinel only observes and alerts; it never blocks or changes the network. Four: secrets are in a mode 600 file and never printed. Five: the demo attack scripts refuse any target except loopback. Also mention the delete and history paths are validated and audited, and that automated security review found and we fixed a symlink issue in the sudo file-ownership code.</a:t>
+              <a:t>Five points. One: strings from the network are hostile and go through one sanitiser. Two: the console is local only, with a token, a strict content-security policy and no way for network text to become markup; the test suite fails if code that builds HTML from strings is added. Three: Raven only observes and alerts; it never blocks or changes the network. Four: secrets are in a mode 600 file and never printed. Five: the demo attack scripts refuse any target except loopback. Also mention the delete and history paths are validated and audited, and that automated security review found and we fixed a symlink issue in the sudo file-ownership code.</a:t>
             </a:r>
             <a:endParaRPr lang="en-US" dirty="0"/>
           </a:p>
@@ -1224,7 +1224,7 @@
           <a:p>
             <a:r>
               <a:rPr lang="en-US" dirty="0"/>
-              <a:t>Sentinel sees what crosses the interface it captures, so it belongs on the gateway: a Mac sharing its connection, where clients appear on bridge100. On a normal laptop on Wi-Fi it only sees that laptop's own traffic. Be clear about the audience: small teams, schools and labs with no analyst, and people learning detection. It is not an enterprise product, not an intrusion prevention system, and does not read encrypted content.</a:t>
+              <a:t>Raven sees what crosses the interface it captures, so it belongs on the gateway: a Mac sharing its connection, where clients appear on bridge100. On a normal laptop on Wi-Fi it only sees that laptop's own traffic. Be clear about the audience: small teams, schools and labs with no analyst, and people learning detection. It is not an enterprise product, not an intrusion prevention system, and does not read encrypted content.</a:t>
             </a:r>
             <a:endParaRPr lang="en-US" dirty="0"/>
           </a:p>
@@ -1840,7 +1840,7 @@
           <a:p>
             <a:r>
               <a:rPr lang="en-US" dirty="0"/>
-              <a:t>Every detection is written to a SQLite database in the user's folder, so it survives restarts. The History tab filters by severity, time and source, searches headline, address, technique or incident id, opens the full explanation and the numbers behind it, exports CSV, and deletes chosen entries (two clicks to confirm, each deletion recorded in an audit log). The same data is available in the terminal with 'sentinel history'.</a:t>
+              <a:t>Every detection is written to a SQLite database in the user's folder, so it survives restarts. The History tab filters by severity, time and source, searches headline, address, technique or incident id, opens the full explanation and the numbers behind it, exports CSV, and deletes chosen entries (two clicks to confirm, each deletion recorded in an audit log). The same data is available in the terminal with 'raven history'.</a:t>
             </a:r>
             <a:endParaRPr lang="en-US" dirty="0"/>
           </a:p>
@@ -2315,7 +2315,7 @@
                 <a:ea typeface="Courier New" pitchFamily="34" charset="-122"/>
                 <a:cs typeface="Courier New" pitchFamily="34" charset="-120"/>
               </a:rPr>
-              <a:t>SENTINEL</a:t>
+              <a:t>RAVEN</a:t>
             </a:r>
             <a:endParaRPr lang="en-US" sz="1000" dirty="0"/>
           </a:p>
@@ -2855,7 +2855,7 @@
                 <a:ea typeface="Calibri" pitchFamily="34" charset="-122"/>
                 <a:cs typeface="Calibri" pitchFamily="34" charset="-120"/>
               </a:rPr>
-              <a:t>Sentinel</a:t>
+              <a:t>Raven</a:t>
             </a:r>
             <a:endParaRPr lang="en-US" sz="6600" dirty="0"/>
           </a:p>
@@ -3074,7 +3074,7 @@
                 <a:ea typeface="Courier New" pitchFamily="34" charset="-122"/>
                 <a:cs typeface="Courier New" pitchFamily="34" charset="-120"/>
               </a:rPr>
-              <a:t>418</a:t>
+              <a:t>462</a:t>
             </a:r>
             <a:endParaRPr lang="en-US" sz="2800" dirty="0"/>
           </a:p>
@@ -3303,7 +3303,7 @@
       </p:sp>
       <p:pic>
         <p:nvPicPr>
-          <p:cNvPr id="18" name="Image 0" descr="Sentinel web console during a live port scan, brute force, beacon and DNS tunnel test: packet monitor, topology and four CRITICAL alerts">    </p:cNvPr>
+          <p:cNvPr id="18" name="Image 0" descr="Raven web console during a live port scan, brute force, beacon and DNS tunnel test: packet monitor, topology and four CRITICAL alerts">    </p:cNvPr>
           <p:cNvPicPr>
             <a:picLocks noChangeAspect="1"/>
           </p:cNvPicPr>
@@ -11183,7 +11183,7 @@
                 <a:ea typeface="Calibri" pitchFamily="34" charset="-122"/>
                 <a:cs typeface="Calibri" pitchFamily="34" charset="-120"/>
               </a:rPr>
-              <a:t>Sentinel never blocks, changes firewall rules or touches the network. A human decides what to do.</a:t>
+              <a:t>Raven never blocks, changes firewall rules or touches the network. A human decides what to do.</a:t>
             </a:r>
             <a:endParaRPr lang="en-US" sz="1250" dirty="0"/>
           </a:p>
@@ -11540,7 +11540,7 @@
                 <a:ea typeface="Courier New" pitchFamily="34" charset="-122"/>
                 <a:cs typeface="Courier New" pitchFamily="34" charset="-120"/>
               </a:rPr>
-              <a:t>51</a:t>
+              <a:t>85</a:t>
             </a:r>
             <a:endParaRPr lang="en-US" sz="7200" dirty="0"/>
           </a:p>
@@ -12234,7 +12234,7 @@
                 <a:ea typeface="Calibri" pitchFamily="34" charset="-122"/>
                 <a:cs typeface="Calibri" pitchFamily="34" charset="-120"/>
               </a:rPr>
-              <a:t>runs Sentinel</a:t>
+              <a:t>runs Raven</a:t>
             </a:r>
             <a:endParaRPr lang="en-US" sz="1400" dirty="0"/>
           </a:p>
@@ -13502,7 +13502,7 @@
                 <a:ea typeface="Courier New" pitchFamily="34" charset="-122"/>
                 <a:cs typeface="Courier New" pitchFamily="34" charset="-120"/>
               </a:rPr>
-              <a:t>$ git clone https://github.com/MRX-72/Hackt0b3r.git sentinel &amp;&amp; cd sentinel</a:t>
+              <a:t>$ git clone https://github.com/MRX-72/Hackt0b3r.git raven &amp;&amp; cd raven</a:t>
             </a:r>
             <a:endParaRPr lang="en-US" sz="1250" dirty="0"/>
           </a:p>
@@ -13542,7 +13542,7 @@
                 <a:ea typeface="Courier New" pitchFamily="34" charset="-122"/>
                 <a:cs typeface="Courier New" pitchFamily="34" charset="-120"/>
               </a:rPr>
-              <a:t>$ sentinel init &amp;&amp; sentinel doctor</a:t>
+              <a:t>$ raven init &amp;&amp; raven doctor</a:t>
             </a:r>
             <a:endParaRPr lang="en-US" sz="1250" dirty="0"/>
           </a:p>
@@ -13693,7 +13693,7 @@
                 <a:ea typeface="Courier New" pitchFamily="34" charset="-122"/>
                 <a:cs typeface="Courier New" pitchFamily="34" charset="-120"/>
               </a:rPr>
-              <a:t>$ sentinel replay demo.pcap</a:t>
+              <a:t>$ raven replay demo.pcap</a:t>
             </a:r>
             <a:endParaRPr lang="en-US" sz="1250" dirty="0"/>
           </a:p>
@@ -13713,7 +13713,7 @@
                 <a:ea typeface="Courier New" pitchFamily="34" charset="-122"/>
                 <a:cs typeface="Courier New" pitchFamily="34" charset="-120"/>
               </a:rPr>
-              <a:t>$ sentinel ui --replay demo.pcap</a:t>
+              <a:t>$ raven ui --replay demo.pcap</a:t>
             </a:r>
             <a:endParaRPr lang="en-US" sz="1250" dirty="0"/>
           </a:p>
@@ -13733,7 +13733,7 @@
                 <a:ea typeface="Courier New" pitchFamily="34" charset="-122"/>
                 <a:cs typeface="Courier New" pitchFamily="34" charset="-120"/>
               </a:rPr>
-              <a:t>$ sentinel history</a:t>
+              <a:t>$ raven history</a:t>
             </a:r>
             <a:endParaRPr lang="en-US" sz="1250" dirty="0"/>
           </a:p>
@@ -13884,7 +13884,7 @@
                 <a:ea typeface="Courier New" pitchFamily="34" charset="-122"/>
                 <a:cs typeface="Courier New" pitchFamily="34" charset="-120"/>
               </a:rPr>
-              <a:t>$ sentinel --config examples/demo-10s.toml ui --iface lo0</a:t>
+              <a:t>$ raven --config examples/demo-10s.toml ui --iface lo0</a:t>
             </a:r>
             <a:endParaRPr lang="en-US" sz="1250" dirty="0"/>
           </a:p>
@@ -14221,7 +14221,7 @@
                 <a:ea typeface="Courier New" pitchFamily="34" charset="-122"/>
                 <a:cs typeface="Courier New" pitchFamily="34" charset="-120"/>
               </a:rPr>
-              <a:t>$ sentinel init</a:t>
+              <a:t>$ raven init</a:t>
             </a:r>
             <a:endParaRPr lang="en-US" sz="1400" dirty="0"/>
           </a:p>
@@ -14984,7 +14984,7 @@
                 <a:ea typeface="Calibri" pitchFamily="34" charset="-122"/>
                 <a:cs typeface="Calibri" pitchFamily="34" charset="-120"/>
               </a:rPr>
-              <a:t>Sentinel: </a:t>
+              <a:t>Raven: </a:t>
             </a:r>
             <a:pPr indent="0" marL="0">
               <a:buNone/>
@@ -18384,7 +18384,7 @@
       </p:sp>
       <p:pic>
         <p:nvPicPr>
-          <p:cNvPr id="6" name="Image 0" descr="Live tab of the Sentinel console">    </p:cNvPr>
+          <p:cNvPr id="6" name="Image 0" descr="Live tab of the Raven console">    </p:cNvPr>
           <p:cNvPicPr>
             <a:picLocks noChangeAspect="1"/>
           </p:cNvPicPr>
@@ -19546,7 +19546,7 @@
                 <a:ea typeface="Calibri" pitchFamily="34" charset="-122"/>
                 <a:cs typeface="Calibri" pitchFamily="34" charset="-120"/>
               </a:rPr>
-              <a:t>SQLite in ~/.sentinel. The same history from any folder.</a:t>
+              <a:t>SQLite in ~/.raven. The same history from any folder.</a:t>
             </a:r>
             <a:endParaRPr lang="en-US" sz="1150" dirty="0"/>
           </a:p>
@@ -19849,7 +19849,7 @@
                 <a:ea typeface="Calibri" pitchFamily="34" charset="-122"/>
                 <a:cs typeface="Calibri" pitchFamily="34" charset="-120"/>
               </a:rPr>
-              <a:t>CSV export, or sentinel history --json for scripts.</a:t>
+              <a:t>CSV export, or raven history --json for scripts.</a:t>
             </a:r>
             <a:endParaRPr lang="en-US" sz="1150" dirty="0"/>
           </a:p>
@@ -22071,7 +22071,7 @@
                 <a:ea typeface="Calibri" pitchFamily="34" charset="-122"/>
                 <a:cs typeface="Calibri" pitchFamily="34" charset="-120"/>
               </a:rPr>
-              <a:t>The same checks as sentinel doctor, refreshed live.</a:t>
+              <a:t>The same checks as raven doctor, refreshed live.</a:t>
             </a:r>
             <a:endParaRPr lang="en-US" sz="1150" dirty="0"/>
           </a:p>

</xml_diff>